<commit_message>
v4.16.0: identity on every title page, design showcase decks, hand-over to the team repository
- Title pages of the four PDFs and both decks: the long name Controller Status Code Management
  Tool, the Software Owner and Administrator on top, the logo; logo in the menu bar, the login page
  and as tab icon (FR-187, app/branding.py, scripts/make_logo.py)
- Design showcase: management deck (11 slides) and team walkthrough (23 slides), each as .pptx and
  .pdf, from real screenshots of a throw-away demo copy; ci.py --showcase (FR-186)
- Hand-over: audited clean export to a team repository (scripts/handover.py), GitHub workflow,
  code owners, pull request template and CONTRIBUTING.md (FR-188); tree.7z removed
- Release folder releases/v4.16.0 with the four PDFs and the two decks
- Test report of this run: 1025 tests, 0 failed, 0 skipped; black, ruff, mypy, bandit, pip-audit clean

Co-Authored-By: Claude Sonnet 5.5 <noreply@anthropic.com>
</commit_message>
<xml_diff>
--- a/releases/v4.16.0/CSCM-Tool_v4.16.0_Design-Showcase-Management.pptx
+++ b/releases/v4.16.0/CSCM-Tool_v4.16.0_Design-Showcase-Management.pptx
@@ -4757,7 +4757,7 @@
                 </a:solidFill>
                 <a:latin typeface="Calibri"/>
               </a:rPr>
-              <a:t>v4.13.0</a:t>
+              <a:t>v4.13.1 / v4.13.2</a:t>
             </a:r>
           </a:p>
         </p:txBody>
@@ -4796,7 +4796,7 @@
                 </a:solidFill>
                 <a:latin typeface="Calibri"/>
               </a:rPr>
-              <a:t>Bulk workflow for the migration — I-70 with I-61 and I-62</a:t>
+              <a:t>Select-all on every list with tick boxes</a:t>
             </a:r>
           </a:p>
         </p:txBody>
@@ -4835,7 +4835,7 @@
                 </a:solidFill>
                 <a:latin typeface="Calibri"/>
               </a:rPr>
-              <a:t>FR-180</a:t>
+              <a:t>FR-181, FR-182</a:t>
             </a:r>
           </a:p>
         </p:txBody>
@@ -4922,7 +4922,7 @@
                 </a:solidFill>
                 <a:latin typeface="Calibri"/>
               </a:rPr>
-              <a:t>v4.13.1 / v4.13.2</a:t>
+              <a:t>v4.14.0</a:t>
             </a:r>
           </a:p>
         </p:txBody>
@@ -4961,7 +4961,7 @@
                 </a:solidFill>
                 <a:latin typeface="Calibri"/>
               </a:rPr>
-              <a:t>Select-all on every list with tick boxes</a:t>
+              <a:t>Dark mode</a:t>
             </a:r>
           </a:p>
         </p:txBody>
@@ -5000,7 +5000,7 @@
                 </a:solidFill>
                 <a:latin typeface="Calibri"/>
               </a:rPr>
-              <a:t>FR-181, FR-182</a:t>
+              <a:t>FR-183</a:t>
             </a:r>
           </a:p>
         </p:txBody>
@@ -5087,7 +5087,7 @@
                 </a:solidFill>
                 <a:latin typeface="Calibri"/>
               </a:rPr>
-              <a:t>v4.14.0</a:t>
+              <a:t>v4.14.1</a:t>
             </a:r>
           </a:p>
         </p:txBody>
@@ -5126,7 +5126,7 @@
                 </a:solidFill>
                 <a:latin typeface="Calibri"/>
               </a:rPr>
-              <a:t>Dark mode</a:t>
+              <a:t>Visible version</a:t>
             </a:r>
           </a:p>
         </p:txBody>
@@ -5165,7 +5165,7 @@
                 </a:solidFill>
                 <a:latin typeface="Calibri"/>
               </a:rPr>
-              <a:t>FR-183</a:t>
+              <a:t>FR-184</a:t>
             </a:r>
           </a:p>
         </p:txBody>
@@ -5252,7 +5252,7 @@
                 </a:solidFill>
                 <a:latin typeface="Calibri"/>
               </a:rPr>
-              <a:t>v4.14.1</a:t>
+              <a:t>v4.15.0</a:t>
             </a:r>
           </a:p>
         </p:txBody>
@@ -5291,7 +5291,7 @@
                 </a:solidFill>
                 <a:latin typeface="Calibri"/>
               </a:rPr>
-              <a:t>Visible version</a:t>
+              <a:t>Release documents as PDF</a:t>
             </a:r>
           </a:p>
         </p:txBody>
@@ -5330,7 +5330,7 @@
                 </a:solidFill>
                 <a:latin typeface="Calibri"/>
               </a:rPr>
-              <a:t>FR-184</a:t>
+              <a:t>FR-185</a:t>
             </a:r>
           </a:p>
         </p:txBody>
@@ -5417,7 +5417,7 @@
                 </a:solidFill>
                 <a:latin typeface="Calibri"/>
               </a:rPr>
-              <a:t>v4.15.0</a:t>
+              <a:t>v4.16.0</a:t>
             </a:r>
           </a:p>
         </p:txBody>
@@ -5456,7 +5456,7 @@
                 </a:solidFill>
                 <a:latin typeface="Calibri"/>
               </a:rPr>
-              <a:t>Release documents as PDF</a:t>
+              <a:t>Design showcase decks</a:t>
             </a:r>
           </a:p>
         </p:txBody>
@@ -5495,7 +5495,7 @@
                 </a:solidFill>
                 <a:latin typeface="Calibri"/>
               </a:rPr>
-              <a:t>FR-185</a:t>
+              <a:t>FR-186, FR-187</a:t>
             </a:r>
           </a:p>
         </p:txBody>
@@ -5621,7 +5621,7 @@
                 </a:solidFill>
                 <a:latin typeface="Calibri"/>
               </a:rPr>
-              <a:t>Design showcase decks</a:t>
+              <a:t>Hand-over to the team repository</a:t>
             </a:r>
           </a:p>
         </p:txBody>
@@ -5660,7 +5660,7 @@
                 </a:solidFill>
                 <a:latin typeface="Calibri"/>
               </a:rPr>
-              <a:t>FR-186, FR-187</a:t>
+              <a:t>FR-188</a:t>
             </a:r>
           </a:p>
         </p:txBody>
@@ -8472,7 +8472,7 @@
                 </a:solidFill>
                 <a:latin typeface="Calibri"/>
               </a:rPr>
-              <a:t>1,019</a:t>
+              <a:t>1,025</a:t>
             </a:r>
           </a:p>
         </p:txBody>
@@ -8724,7 +8724,7 @@
                 </a:solidFill>
                 <a:latin typeface="Calibri"/>
               </a:rPr>
-              <a:t>215</a:t>
+              <a:t>216</a:t>
             </a:r>
           </a:p>
         </p:txBody>

</xml_diff>